<commit_message>
shadows added and ui changed
</commit_message>
<xml_diff>
--- a/EcoRoads_corrected.pptx
+++ b/EcoRoads_corrected.pptx
@@ -25,7 +25,8 @@
     <p:sldId id="270" r:id="rId16"/>
     <p:sldId id="278" r:id="rId28"/>
     <p:sldId id="262" r:id="rId17"/>
-    <p:sldId id="276" r:id="rId18"/>
+    <p:sldId id="280" r:id="rId30"/>
+    <p:sldId id="281" r:id="rId31"/>
     <p:sldId id="275" r:id="rId19"/>
     <p:sldId id="279" r:id="rId29"/>
     <p:sldId id="277" r:id="rId20"/>
@@ -4810,48 +4811,6 @@
       </p:grpSpPr>
       <p:sp>
         <p:nvSpPr>
-          <p:cNvPr id="15" name="Text 9"/>
-          <p:cNvSpPr/>
-          <p:nvPr/>
-        </p:nvSpPr>
-        <p:spPr>
-          <a:xfrm>
-            <a:off x="1289304" y="3648456"/>
-            <a:ext cx="6894576" cy="685800"/>
-          </a:xfrm>
-          <a:prstGeom prst="rect">
-            <a:avLst/>
-          </a:prstGeom>
-          <a:noFill/>
-          <a:ln/>
-        </p:spPr>
-        <p:txBody>
-          <a:bodyPr wrap="square" lIns="0" tIns="0" rIns="0" bIns="0" rtlCol="0" anchor="t"/>
-          <a:lstStyle/>
-          <a:p>
-            <a:pPr marL="0" indent="0">
-              <a:lnSpc>
-                <a:spcPct val="110000"/>
-              </a:lnSpc>
-              <a:buNone/>
-            </a:pPr>
-            <a:r>
-              <a:rPr lang="en-US" sz="1200" dirty="0">
-                <a:solidFill>
-                  <a:srgbClr val="1A1A1A"/>
-                </a:solidFill>
-                <a:latin typeface="Calibri" pitchFamily="34" charset="0"/>
-                <a:ea typeface="Calibri" pitchFamily="34" charset="-122"/>
-                <a:cs typeface="Calibri" pitchFamily="34" charset="-120"/>
-              </a:rPr>
-              <a:t>.</a:t>
-            </a:r>
-            <a:endParaRPr lang="en-US" sz="1350" dirty="0"/>
-          </a:p>
-        </p:txBody>
-      </p:sp>
-      <p:sp>
-        <p:nvSpPr>
           <p:cNvPr id="16" name="Text 10"/>
           <p:cNvSpPr/>
           <p:nvPr/>
@@ -4953,73 +4912,103 @@
           <a:p>
             <a:r>
               <a:rPr lang="en-US" sz="3600" dirty="0"/>
-              <a:t>SCREENSHOTS</a:t>
+              <a:t>FIELD TEST</a:t>
             </a:r>
             <a:endParaRPr lang="en-IN" dirty="0"/>
           </a:p>
         </p:txBody>
       </p:sp>
-    </p:spTree>
-  </p:cSld>
-  <p:clrMapOvr>
-    <a:masterClrMapping/>
-  </p:clrMapOvr>
-</p:sld>
-</file>
-
-<file path=ppt/slides/slide17.xml><?xml version="1.0" encoding="utf-8"?>
-<p:sld xmlns:a="http://schemas.openxmlformats.org/drawingml/2006/main" xmlns:r="http://schemas.openxmlformats.org/officeDocument/2006/relationships" xmlns:p="http://schemas.openxmlformats.org/presentationml/2006/main">
-  <p:cSld>
-    <p:spTree>
-      <p:nvGrpSpPr>
-        <p:cNvPr id="1" name=""/>
-        <p:cNvGrpSpPr/>
-        <p:nvPr/>
-      </p:nvGrpSpPr>
-      <p:grpSpPr>
-        <a:xfrm>
-          <a:off x="0" y="0"/>
-          <a:ext cx="0" cy="0"/>
-          <a:chOff x="0" y="0"/>
-          <a:chExt cx="0" cy="0"/>
-        </a:xfrm>
-      </p:grpSpPr>
       <p:pic>
         <p:nvPicPr>
-          <p:cNvPr id="3" name="Picture 2">
-            <a:extLst>
-              <a:ext uri="{FF2B5EF4-FFF2-40B4-BE49-F238E27FC236}">
-                <a16:creationId xmlns:a16="http://schemas.microsoft.com/office/drawing/2014/main" id="{9C173EC9-4701-CE56-1EEB-9D944D3978D0}"/>
-              </a:ext>
-            </a:extLst>
-          </p:cNvPr>
+          <p:cNvPr id="20" name="Phone sensor page on the windscreen" descr="Phone sensor page on the windscreen"/>
           <p:cNvPicPr>
             <a:picLocks noChangeAspect="1"/>
           </p:cNvPicPr>
           <p:nvPr/>
         </p:nvPicPr>
         <p:blipFill>
-          <a:blip r:embed="rId2"/>
+          <a:blip r:embed="rId4"/>
           <a:stretch>
             <a:fillRect/>
           </a:stretch>
         </p:blipFill>
         <p:spPr>
           <a:xfrm>
-            <a:off x="1354" y="0"/>
-            <a:ext cx="9141292" cy="5143500"/>
-          </a:xfrm>
-          <a:prstGeom prst="rect">
-            <a:avLst/>
-          </a:prstGeom>
+            <a:off x="868680" y="713232"/>
+            <a:ext cx="1979864" cy="3246120"/>
+          </a:xfrm>
+          <a:prstGeom prst="rect">
+            <a:avLst/>
+          </a:prstGeom>
+          <a:ln w="12700">
+            <a:solidFill>
+              <a:srgbClr val="1F3864"/>
+            </a:solidFill>
+          </a:ln>
         </p:spPr>
       </p:pic>
+      <p:pic>
+        <p:nvPicPr>
+          <p:cNvPr id="21" name="YOLOv8n detection on the laptop" descr="YOLOv8n detection on the laptop"/>
+          <p:cNvPicPr>
+            <a:picLocks noChangeAspect="1"/>
+          </p:cNvPicPr>
+          <p:nvPr/>
+        </p:nvPicPr>
+        <p:blipFill>
+          <a:blip r:embed="rId5"/>
+          <a:stretch>
+            <a:fillRect/>
+          </a:stretch>
+        </p:blipFill>
+        <p:spPr>
+          <a:xfrm>
+            <a:off x="3154680" y="868680"/>
+            <a:ext cx="4480560" cy="2837688"/>
+          </a:xfrm>
+          <a:prstGeom prst="rect">
+            <a:avLst/>
+          </a:prstGeom>
+          <a:ln w="12700">
+            <a:solidFill>
+              <a:srgbClr val="1F3864"/>
+            </a:solidFill>
+          </a:ln>
+        </p:spPr>
+      </p:pic>
+      <p:sp>
+        <p:nvSpPr>
+          <p:cNvPr id="22" name="Caption 22"/>
+          <p:cNvSpPr txBox="1"/>
+          <p:nvPr/>
+        </p:nvSpPr>
+        <p:spPr>
+          <a:xfrm>
+            <a:off x="3154680" y="3779520"/>
+            <a:ext cx="4480560" cy="411480"/>
+          </a:xfrm>
+          <a:prstGeom prst="rect">
+            <a:avLst/>
+          </a:prstGeom>
+          <a:noFill/>
+        </p:spPr>
+        <p:txBody>
+          <a:bodyPr wrap="square" lIns="0" tIns="0" rIns="0" bIns="0"/>
+          <a:lstStyle/>
+          <a:p>
+            <a:pPr algn="ctr"/>
+            <a:r>
+              <a:rPr lang="en-IN" sz="1100" dirty="0">
+                <a:solidFill>
+                  <a:srgbClr val="1A1A1A"/>
+                </a:solidFill>
+              </a:rPr>
+              <a:t>Laptop: YOLOv8n detection (confidence 0.62). Phone: 720×1280 at 13.8 fps, GPS ±4 m, motion live, 22 detections logged, 0 waiting to sync.</a:t>
+            </a:r>
+          </a:p>
+        </p:txBody>
+      </p:sp>
     </p:spTree>
-    <p:extLst>
-      <p:ext uri="{BB962C8B-B14F-4D97-AF65-F5344CB8AC3E}">
-        <p14:creationId xmlns:p14="http://schemas.microsoft.com/office/powerpoint/2010/main" val="43278891"/>
-      </p:ext>
-    </p:extLst>
   </p:cSld>
   <p:clrMapOvr>
     <a:masterClrMapping/>
@@ -6469,7 +6458,7 @@
                 </a:solidFill>
                 <a:latin typeface="Calibri"/>
               </a:rPr>
-              <a:t>22</a:t>
+              <a:t>23</a:t>
             </a:r>
           </a:p>
         </p:txBody>
@@ -6795,11 +6784,11 @@
             </a:pPr>
             <a:r>
               <a:rPr lang="en-IN" b="1" dirty="0"/>
-              <a:t>De-duplication:</a:t>
+              <a:t>Field drive:</a:t>
             </a:r>
             <a:r>
               <a:rPr lang="en-IN" dirty="0"/>
-              <a:t> repeat reports merged into one pothole</a:t>
+              <a:t> 13.8 fps, GPS ±4 m, 13 hazards, 2 auto tickets</a:t>
             </a:r>
           </a:p>
           <a:p>
@@ -7145,6 +7134,424 @@
         <p14:creationId xmlns:p14="http://schemas.microsoft.com/office/powerpoint/2010/main" val="2773293719"/>
       </p:ext>
     </p:extLst>
+  </p:cSld>
+  <p:clrMapOvr>
+    <a:masterClrMapping/>
+  </p:clrMapOvr>
+</p:sld>
+</file>
+
+<file path=ppt/slides/slide23.xml><?xml version="1.0" encoding="utf-8"?>
+<p:sld xmlns:a="http://schemas.openxmlformats.org/drawingml/2006/main" xmlns:r="http://schemas.openxmlformats.org/officeDocument/2006/relationships" xmlns:p="http://schemas.openxmlformats.org/presentationml/2006/main">
+  <p:cSld name="Slide 7">
+    <p:bg>
+      <p:bgPr>
+        <a:blipFill dpi="0" rotWithShape="1">
+          <a:blip r:embed="rId3">
+            <a:lum/>
+          </a:blip>
+          <a:srcRect/>
+          <a:stretch>
+            <a:fillRect/>
+          </a:stretch>
+        </a:blipFill>
+        <a:effectLst/>
+      </p:bgPr>
+    </p:bg>
+    <p:spTree>
+      <p:nvGrpSpPr>
+        <p:cNvPr id="1" name=""/>
+        <p:cNvGrpSpPr/>
+        <p:nvPr/>
+      </p:nvGrpSpPr>
+      <p:grpSpPr>
+        <a:xfrm>
+          <a:off x="0" y="0"/>
+          <a:ext cx="0" cy="0"/>
+          <a:chOff x="0" y="0"/>
+          <a:chExt cx="0" cy="0"/>
+        </a:xfrm>
+      </p:grpSpPr>
+      <p:sp>
+        <p:nvSpPr>
+          <p:cNvPr id="16" name="Text 10"/>
+          <p:cNvSpPr/>
+          <p:nvPr/>
+        </p:nvSpPr>
+        <p:spPr>
+          <a:xfrm>
+            <a:off x="2468880" y="4727448"/>
+            <a:ext cx="4206240" cy="274320"/>
+          </a:xfrm>
+          <a:prstGeom prst="rect">
+            <a:avLst/>
+          </a:prstGeom>
+          <a:noFill/>
+          <a:ln/>
+        </p:spPr>
+        <p:txBody>
+          <a:bodyPr wrap="square" lIns="0" tIns="0" rIns="0" bIns="0" rtlCol="0" anchor="ctr"/>
+          <a:lstStyle/>
+          <a:p>
+            <a:pPr marL="0" indent="0" algn="ctr">
+              <a:buNone/>
+            </a:pPr>
+            <a:r>
+              <a:rPr lang="en-US" sz="1100" dirty="0">
+                <a:solidFill>
+                  <a:srgbClr val="595959"/>
+                </a:solidFill>
+                <a:latin typeface="Calibri" pitchFamily="34" charset="0"/>
+                <a:ea typeface="Calibri" pitchFamily="34" charset="-122"/>
+                <a:cs typeface="Calibri" pitchFamily="34" charset="-120"/>
+              </a:rPr>
+              <a:t>Department of Computer Science</a:t>
+            </a:r>
+            <a:endParaRPr lang="en-US" sz="1100" dirty="0"/>
+          </a:p>
+        </p:txBody>
+      </p:sp>
+      <p:sp>
+        <p:nvSpPr>
+          <p:cNvPr id="17" name="Text 11"/>
+          <p:cNvSpPr/>
+          <p:nvPr/>
+        </p:nvSpPr>
+        <p:spPr>
+          <a:xfrm>
+            <a:off x="8275320" y="4727448"/>
+            <a:ext cx="457200" cy="274320"/>
+          </a:xfrm>
+          <a:prstGeom prst="rect">
+            <a:avLst/>
+          </a:prstGeom>
+          <a:noFill/>
+          <a:ln/>
+        </p:spPr>
+        <p:txBody>
+          <a:bodyPr wrap="square" lIns="0" tIns="0" rIns="0" bIns="0" rtlCol="0" anchor="ctr"/>
+          <a:lstStyle/>
+          <a:p>
+            <a:pPr algn="ctr"/>
+            <a:r>
+              <a:rPr sz="900">
+                <a:solidFill>
+                  <a:srgbClr val="FFFFFF"/>
+                </a:solidFill>
+                <a:latin typeface="Calibri"/>
+              </a:rPr>
+              <a:t>18</a:t>
+            </a:r>
+          </a:p>
+        </p:txBody>
+      </p:sp>
+      <p:sp>
+        <p:nvSpPr>
+          <p:cNvPr id="19" name="TextBox 18">
+            <a:extLst>
+              <a:ext uri="{FF2B5EF4-FFF2-40B4-BE49-F238E27FC236}">
+                <a16:creationId xmlns:a16="http://schemas.microsoft.com/office/drawing/2014/main" id="{246A1F20-7F45-8527-9C48-57081F51BCCD}"/>
+              </a:ext>
+            </a:extLst>
+          </p:cNvPr>
+          <p:cNvSpPr txBox="1"/>
+          <p:nvPr/>
+        </p:nvSpPr>
+        <p:spPr>
+          <a:xfrm>
+            <a:off x="2286000" y="0"/>
+            <a:ext cx="4572000" cy="646331"/>
+          </a:xfrm>
+          <a:prstGeom prst="rect">
+            <a:avLst/>
+          </a:prstGeom>
+          <a:noFill/>
+        </p:spPr>
+        <p:txBody>
+          <a:bodyPr wrap="square">
+            <a:spAutoFit/>
+          </a:bodyPr>
+          <a:lstStyle/>
+          <a:p>
+            <a:r>
+              <a:rPr lang="en-US" sz="3600" dirty="0"/>
+              <a:t>DASHBOARD</a:t>
+            </a:r>
+            <a:endParaRPr lang="en-IN" dirty="0"/>
+          </a:p>
+        </p:txBody>
+      </p:sp>
+      <p:pic>
+        <p:nvPicPr>
+          <p:cNvPr id="20" name="Registering a municipality" descr="Registering a municipality"/>
+          <p:cNvPicPr>
+            <a:picLocks noChangeAspect="1"/>
+          </p:cNvPicPr>
+          <p:nvPr/>
+        </p:nvPicPr>
+        <p:blipFill>
+          <a:blip r:embed="rId4"/>
+          <a:stretch>
+            <a:fillRect/>
+          </a:stretch>
+        </p:blipFill>
+        <p:spPr>
+          <a:xfrm>
+            <a:off x="1234440" y="713232"/>
+            <a:ext cx="6675120" cy="2980648"/>
+          </a:xfrm>
+          <a:prstGeom prst="rect">
+            <a:avLst/>
+          </a:prstGeom>
+          <a:ln w="12700">
+            <a:solidFill>
+              <a:srgbClr val="1F3864"/>
+            </a:solidFill>
+          </a:ln>
+        </p:spPr>
+      </p:pic>
+      <p:sp>
+        <p:nvSpPr>
+          <p:cNvPr id="21" name="Caption 21"/>
+          <p:cNvSpPr txBox="1"/>
+          <p:nvPr/>
+        </p:nvSpPr>
+        <p:spPr>
+          <a:xfrm>
+            <a:off x="1234440" y="3767032"/>
+            <a:ext cx="6675120" cy="274320"/>
+          </a:xfrm>
+          <a:prstGeom prst="rect">
+            <a:avLst/>
+          </a:prstGeom>
+          <a:noFill/>
+        </p:spPr>
+        <p:txBody>
+          <a:bodyPr wrap="square" lIns="0" tIns="0" rIns="0" bIns="0"/>
+          <a:lstStyle/>
+          <a:p>
+            <a:pPr algn="ctr"/>
+            <a:r>
+              <a:rPr lang="en-IN" sz="1100" dirty="0">
+                <a:solidFill>
+                  <a:srgbClr val="1A1A1A"/>
+                </a:solidFill>
+              </a:rPr>
+              <a:t>A municipality registers its area (centre + 800 m radius) and gets a private staff link.</a:t>
+            </a:r>
+          </a:p>
+        </p:txBody>
+      </p:sp>
+    </p:spTree>
+  </p:cSld>
+  <p:clrMapOvr>
+    <a:masterClrMapping/>
+  </p:clrMapOvr>
+</p:sld>
+</file>
+
+<file path=ppt/slides/slide24.xml><?xml version="1.0" encoding="utf-8"?>
+<p:sld xmlns:a="http://schemas.openxmlformats.org/drawingml/2006/main" xmlns:r="http://schemas.openxmlformats.org/officeDocument/2006/relationships" xmlns:p="http://schemas.openxmlformats.org/presentationml/2006/main">
+  <p:cSld name="Slide 7">
+    <p:bg>
+      <p:bgPr>
+        <a:blipFill dpi="0" rotWithShape="1">
+          <a:blip r:embed="rId3">
+            <a:lum/>
+          </a:blip>
+          <a:srcRect/>
+          <a:stretch>
+            <a:fillRect/>
+          </a:stretch>
+        </a:blipFill>
+        <a:effectLst/>
+      </p:bgPr>
+    </p:bg>
+    <p:spTree>
+      <p:nvGrpSpPr>
+        <p:cNvPr id="1" name=""/>
+        <p:cNvGrpSpPr/>
+        <p:nvPr/>
+      </p:nvGrpSpPr>
+      <p:grpSpPr>
+        <a:xfrm>
+          <a:off x="0" y="0"/>
+          <a:ext cx="0" cy="0"/>
+          <a:chOff x="0" y="0"/>
+          <a:chExt cx="0" cy="0"/>
+        </a:xfrm>
+      </p:grpSpPr>
+      <p:sp>
+        <p:nvSpPr>
+          <p:cNvPr id="16" name="Text 10"/>
+          <p:cNvSpPr/>
+          <p:nvPr/>
+        </p:nvSpPr>
+        <p:spPr>
+          <a:xfrm>
+            <a:off x="2468880" y="4727448"/>
+            <a:ext cx="4206240" cy="274320"/>
+          </a:xfrm>
+          <a:prstGeom prst="rect">
+            <a:avLst/>
+          </a:prstGeom>
+          <a:noFill/>
+          <a:ln/>
+        </p:spPr>
+        <p:txBody>
+          <a:bodyPr wrap="square" lIns="0" tIns="0" rIns="0" bIns="0" rtlCol="0" anchor="ctr"/>
+          <a:lstStyle/>
+          <a:p>
+            <a:pPr marL="0" indent="0" algn="ctr">
+              <a:buNone/>
+            </a:pPr>
+            <a:r>
+              <a:rPr lang="en-US" sz="1100" dirty="0">
+                <a:solidFill>
+                  <a:srgbClr val="595959"/>
+                </a:solidFill>
+                <a:latin typeface="Calibri" pitchFamily="34" charset="0"/>
+                <a:ea typeface="Calibri" pitchFamily="34" charset="-122"/>
+                <a:cs typeface="Calibri" pitchFamily="34" charset="-120"/>
+              </a:rPr>
+              <a:t>Department of Computer Science</a:t>
+            </a:r>
+            <a:endParaRPr lang="en-US" sz="1100" dirty="0"/>
+          </a:p>
+        </p:txBody>
+      </p:sp>
+      <p:sp>
+        <p:nvSpPr>
+          <p:cNvPr id="17" name="Text 11"/>
+          <p:cNvSpPr/>
+          <p:nvPr/>
+        </p:nvSpPr>
+        <p:spPr>
+          <a:xfrm>
+            <a:off x="8275320" y="4727448"/>
+            <a:ext cx="457200" cy="274320"/>
+          </a:xfrm>
+          <a:prstGeom prst="rect">
+            <a:avLst/>
+          </a:prstGeom>
+          <a:noFill/>
+          <a:ln/>
+        </p:spPr>
+        <p:txBody>
+          <a:bodyPr wrap="square" lIns="0" tIns="0" rIns="0" bIns="0" rtlCol="0" anchor="ctr"/>
+          <a:lstStyle/>
+          <a:p>
+            <a:pPr algn="ctr"/>
+            <a:r>
+              <a:rPr sz="900">
+                <a:solidFill>
+                  <a:srgbClr val="FFFFFF"/>
+                </a:solidFill>
+                <a:latin typeface="Calibri"/>
+              </a:rPr>
+              <a:t>19</a:t>
+            </a:r>
+          </a:p>
+        </p:txBody>
+      </p:sp>
+      <p:sp>
+        <p:nvSpPr>
+          <p:cNvPr id="19" name="TextBox 18">
+            <a:extLst>
+              <a:ext uri="{FF2B5EF4-FFF2-40B4-BE49-F238E27FC236}">
+                <a16:creationId xmlns:a16="http://schemas.microsoft.com/office/drawing/2014/main" id="{246A1F20-7F45-8527-9C48-57081F51BCCD}"/>
+              </a:ext>
+            </a:extLst>
+          </p:cNvPr>
+          <p:cNvSpPr txBox="1"/>
+          <p:nvPr/>
+        </p:nvSpPr>
+        <p:spPr>
+          <a:xfrm>
+            <a:off x="2286000" y="0"/>
+            <a:ext cx="4572000" cy="646331"/>
+          </a:xfrm>
+          <a:prstGeom prst="rect">
+            <a:avLst/>
+          </a:prstGeom>
+          <a:noFill/>
+        </p:spPr>
+        <p:txBody>
+          <a:bodyPr wrap="square">
+            <a:spAutoFit/>
+          </a:bodyPr>
+          <a:lstStyle/>
+          <a:p>
+            <a:r>
+              <a:rPr lang="en-US" sz="3600" dirty="0"/>
+              <a:t>AUTO TICKETS</a:t>
+            </a:r>
+            <a:endParaRPr lang="en-IN" dirty="0"/>
+          </a:p>
+        </p:txBody>
+      </p:sp>
+      <p:pic>
+        <p:nvPicPr>
+          <p:cNvPr id="20" name="Hazards and automatic tickets" descr="Hazards and automatic tickets"/>
+          <p:cNvPicPr>
+            <a:picLocks noChangeAspect="1"/>
+          </p:cNvPicPr>
+          <p:nvPr/>
+        </p:nvPicPr>
+        <p:blipFill>
+          <a:blip r:embed="rId4"/>
+          <a:stretch>
+            <a:fillRect/>
+          </a:stretch>
+        </p:blipFill>
+        <p:spPr>
+          <a:xfrm>
+            <a:off x="1234440" y="713232"/>
+            <a:ext cx="6675120" cy="3030978"/>
+          </a:xfrm>
+          <a:prstGeom prst="rect">
+            <a:avLst/>
+          </a:prstGeom>
+          <a:ln w="12700">
+            <a:solidFill>
+              <a:srgbClr val="1F3864"/>
+            </a:solidFill>
+          </a:ln>
+        </p:spPr>
+      </p:pic>
+      <p:sp>
+        <p:nvSpPr>
+          <p:cNvPr id="21" name="Caption 21"/>
+          <p:cNvSpPr txBox="1"/>
+          <p:nvPr/>
+        </p:nvSpPr>
+        <p:spPr>
+          <a:xfrm>
+            <a:off x="1234440" y="3817362"/>
+            <a:ext cx="6675120" cy="274320"/>
+          </a:xfrm>
+          <a:prstGeom prst="rect">
+            <a:avLst/>
+          </a:prstGeom>
+          <a:noFill/>
+        </p:spPr>
+        <p:txBody>
+          <a:bodyPr wrap="square" lIns="0" tIns="0" rIns="0" bIns="0"/>
+          <a:lstStyle/>
+          <a:p>
+            <a:pPr algn="ctr"/>
+            <a:r>
+              <a:rPr lang="en-IN" sz="1100" dirty="0">
+                <a:solidFill>
+                  <a:srgbClr val="1A1A1A"/>
+                </a:solidFill>
+              </a:rPr>
+              <a:t>13 clustered hazards, the municipal office (Haversine distance) and 2 tickets raised automatically after 3 detections.</a:t>
+            </a:r>
+          </a:p>
+        </p:txBody>
+      </p:sp>
+    </p:spTree>
   </p:cSld>
   <p:clrMapOvr>
     <a:masterClrMapping/>

</xml_diff>